<commit_message>
fix link to DDAR Ch 8 fixes #3
</commit_message>
<xml_diff>
--- a/lectures/03-Twoway1.pptx
+++ b/lectures/03-Twoway1.pptx
@@ -444,7 +444,7 @@
           <a:p>
             <a:fld id="{08BD4FA9-F3CE-45B3-A980-C331C6F1EF65}" type="datetimeFigureOut">
               <a:rPr lang="en-US" smtClean="0"/>
-              <a:t>1/21/2026</a:t>
+              <a:t>1/22/2026</a:t>
             </a:fld>
             <a:endParaRPr lang="en-US"/>
           </a:p>
@@ -609,7 +609,7 @@
           <a:p>
             <a:fld id="{B1271872-C532-4BFE-903F-C7072979174B}" type="datetimeFigureOut">
               <a:rPr lang="en-US" smtClean="0"/>
-              <a:t>1/21/2026</a:t>
+              <a:t>1/22/2026</a:t>
             </a:fld>
             <a:endParaRPr lang="en-US"/>
           </a:p>
@@ -1339,7 +1339,7 @@
           <a:p>
             <a:fld id="{EAAD3657-2200-4D14-82C0-10C39B0F0F06}" type="datetime1">
               <a:rPr lang="en-US" smtClean="0"/>
-              <a:t>1/21/2026</a:t>
+              <a:t>1/22/2026</a:t>
             </a:fld>
             <a:endParaRPr lang="en-US"/>
           </a:p>
@@ -1507,7 +1507,7 @@
           <a:p>
             <a:fld id="{11BBAF55-A85E-4993-914E-FC1E5AA7DF24}" type="datetime1">
               <a:rPr lang="en-US" smtClean="0"/>
-              <a:t>1/21/2026</a:t>
+              <a:t>1/22/2026</a:t>
             </a:fld>
             <a:endParaRPr lang="en-US"/>
           </a:p>
@@ -1685,7 +1685,7 @@
           <a:p>
             <a:fld id="{39816E07-E1DB-44A4-A5E5-9F4B54E8C933}" type="datetime1">
               <a:rPr lang="en-US" smtClean="0"/>
-              <a:t>1/21/2026</a:t>
+              <a:t>1/22/2026</a:t>
             </a:fld>
             <a:endParaRPr lang="en-US"/>
           </a:p>
@@ -1870,7 +1870,7 @@
           <a:p>
             <a:fld id="{C2B1AD17-B813-4477-8AFE-B1860CC59113}" type="datetime1">
               <a:rPr lang="en-US" smtClean="0"/>
-              <a:t>1/21/2026</a:t>
+              <a:t>1/22/2026</a:t>
             </a:fld>
             <a:endParaRPr lang="en-US"/>
           </a:p>
@@ -2115,7 +2115,7 @@
           <a:p>
             <a:fld id="{D0975C0D-5C9E-48CC-8D31-F42D19FA8F7A}" type="datetime1">
               <a:rPr lang="en-US" smtClean="0"/>
-              <a:t>1/21/2026</a:t>
+              <a:t>1/22/2026</a:t>
             </a:fld>
             <a:endParaRPr lang="en-US"/>
           </a:p>
@@ -2400,7 +2400,7 @@
           <a:p>
             <a:fld id="{28657551-0F2B-4F09-86FD-F7994CE83DC5}" type="datetime1">
               <a:rPr lang="en-US" smtClean="0"/>
-              <a:t>1/21/2026</a:t>
+              <a:t>1/22/2026</a:t>
             </a:fld>
             <a:endParaRPr lang="en-US"/>
           </a:p>
@@ -2819,7 +2819,7 @@
           <a:p>
             <a:fld id="{3929D2B2-4200-46B9-96C3-02A55D5FAA00}" type="datetime1">
               <a:rPr lang="en-US" smtClean="0"/>
-              <a:t>1/21/2026</a:t>
+              <a:t>1/22/2026</a:t>
             </a:fld>
             <a:endParaRPr lang="en-US"/>
           </a:p>
@@ -2936,7 +2936,7 @@
           <a:p>
             <a:fld id="{41FF7722-74E8-497F-A072-89677A2C2373}" type="datetime1">
               <a:rPr lang="en-US" smtClean="0"/>
-              <a:t>1/21/2026</a:t>
+              <a:t>1/22/2026</a:t>
             </a:fld>
             <a:endParaRPr lang="en-US"/>
           </a:p>
@@ -3031,7 +3031,7 @@
           <a:p>
             <a:fld id="{BD26212E-B46B-426F-AE59-AA326827D9E0}" type="datetime1">
               <a:rPr lang="en-US" smtClean="0"/>
-              <a:t>1/21/2026</a:t>
+              <a:t>1/22/2026</a:t>
             </a:fld>
             <a:endParaRPr lang="en-US"/>
           </a:p>
@@ -3306,7 +3306,7 @@
           <a:p>
             <a:fld id="{FB9B81E8-09EA-4684-A39F-38DE1E49D20C}" type="datetime1">
               <a:rPr lang="en-US" smtClean="0"/>
-              <a:t>1/21/2026</a:t>
+              <a:t>1/22/2026</a:t>
             </a:fld>
             <a:endParaRPr lang="en-US"/>
           </a:p>
@@ -3558,7 +3558,7 @@
           <a:p>
             <a:fld id="{35C5CC5F-056C-4047-9A5C-9F5B4BED129B}" type="datetime1">
               <a:rPr lang="en-US" smtClean="0"/>
-              <a:t>1/21/2026</a:t>
+              <a:t>1/22/2026</a:t>
             </a:fld>
             <a:endParaRPr lang="en-US"/>
           </a:p>
@@ -3772,7 +3772,7 @@
           <a:p>
             <a:fld id="{E8171053-07BD-4A17-AC24-0A22EAA36098}" type="datetime1">
               <a:rPr lang="en-US" smtClean="0"/>
-              <a:t>1/21/2026</a:t>
+              <a:t>1/22/2026</a:t>
             </a:fld>
             <a:endParaRPr lang="en-US"/>
           </a:p>
@@ -15466,83 +15466,83 @@
           <a:custGeom>
             <a:avLst/>
             <a:gdLst>
-              <a:gd name="connsiteX0" fmla="*/ 0 w 2440858"/>
-              <a:gd name="connsiteY0" fmla="*/ 0 h 722531"/>
-              <a:gd name="connsiteX1" fmla="*/ 463763 w 2440858"/>
-              <a:gd name="connsiteY1" fmla="*/ 0 h 722531"/>
-              <a:gd name="connsiteX2" fmla="*/ 878709 w 2440858"/>
-              <a:gd name="connsiteY2" fmla="*/ 0 h 722531"/>
-              <a:gd name="connsiteX3" fmla="*/ 1415698 w 2440858"/>
-              <a:gd name="connsiteY3" fmla="*/ 0 h 722531"/>
-              <a:gd name="connsiteX4" fmla="*/ 1879461 w 2440858"/>
-              <a:gd name="connsiteY4" fmla="*/ 0 h 722531"/>
-              <a:gd name="connsiteX5" fmla="*/ 2440858 w 2440858"/>
-              <a:gd name="connsiteY5" fmla="*/ 0 h 722531"/>
-              <a:gd name="connsiteX6" fmla="*/ 2440858 w 2440858"/>
-              <a:gd name="connsiteY6" fmla="*/ 375716 h 722531"/>
-              <a:gd name="connsiteX7" fmla="*/ 2440858 w 2440858"/>
-              <a:gd name="connsiteY7" fmla="*/ 722531 h 722531"/>
-              <a:gd name="connsiteX8" fmla="*/ 1952686 w 2440858"/>
-              <a:gd name="connsiteY8" fmla="*/ 722531 h 722531"/>
-              <a:gd name="connsiteX9" fmla="*/ 1537741 w 2440858"/>
-              <a:gd name="connsiteY9" fmla="*/ 722531 h 722531"/>
-              <a:gd name="connsiteX10" fmla="*/ 1049569 w 2440858"/>
-              <a:gd name="connsiteY10" fmla="*/ 722531 h 722531"/>
-              <a:gd name="connsiteX11" fmla="*/ 561397 w 2440858"/>
-              <a:gd name="connsiteY11" fmla="*/ 722531 h 722531"/>
-              <a:gd name="connsiteX12" fmla="*/ 0 w 2440858"/>
-              <a:gd name="connsiteY12" fmla="*/ 722531 h 722531"/>
-              <a:gd name="connsiteX13" fmla="*/ 0 w 2440858"/>
-              <a:gd name="connsiteY13" fmla="*/ 346815 h 722531"/>
-              <a:gd name="connsiteX14" fmla="*/ 0 w 2440858"/>
-              <a:gd name="connsiteY14" fmla="*/ 0 h 722531"/>
+              <a:gd name="csX0" fmla="*/ 0 w 2440858"/>
+              <a:gd name="csY0" fmla="*/ 0 h 722531"/>
+              <a:gd name="csX1" fmla="*/ 463763 w 2440858"/>
+              <a:gd name="csY1" fmla="*/ 0 h 722531"/>
+              <a:gd name="csX2" fmla="*/ 878709 w 2440858"/>
+              <a:gd name="csY2" fmla="*/ 0 h 722531"/>
+              <a:gd name="csX3" fmla="*/ 1415698 w 2440858"/>
+              <a:gd name="csY3" fmla="*/ 0 h 722531"/>
+              <a:gd name="csX4" fmla="*/ 1879461 w 2440858"/>
+              <a:gd name="csY4" fmla="*/ 0 h 722531"/>
+              <a:gd name="csX5" fmla="*/ 2440858 w 2440858"/>
+              <a:gd name="csY5" fmla="*/ 0 h 722531"/>
+              <a:gd name="csX6" fmla="*/ 2440858 w 2440858"/>
+              <a:gd name="csY6" fmla="*/ 375716 h 722531"/>
+              <a:gd name="csX7" fmla="*/ 2440858 w 2440858"/>
+              <a:gd name="csY7" fmla="*/ 722531 h 722531"/>
+              <a:gd name="csX8" fmla="*/ 1952686 w 2440858"/>
+              <a:gd name="csY8" fmla="*/ 722531 h 722531"/>
+              <a:gd name="csX9" fmla="*/ 1537741 w 2440858"/>
+              <a:gd name="csY9" fmla="*/ 722531 h 722531"/>
+              <a:gd name="csX10" fmla="*/ 1049569 w 2440858"/>
+              <a:gd name="csY10" fmla="*/ 722531 h 722531"/>
+              <a:gd name="csX11" fmla="*/ 561397 w 2440858"/>
+              <a:gd name="csY11" fmla="*/ 722531 h 722531"/>
+              <a:gd name="csX12" fmla="*/ 0 w 2440858"/>
+              <a:gd name="csY12" fmla="*/ 722531 h 722531"/>
+              <a:gd name="csX13" fmla="*/ 0 w 2440858"/>
+              <a:gd name="csY13" fmla="*/ 346815 h 722531"/>
+              <a:gd name="csX14" fmla="*/ 0 w 2440858"/>
+              <a:gd name="csY14" fmla="*/ 0 h 722531"/>
             </a:gdLst>
             <a:ahLst/>
             <a:cxnLst>
               <a:cxn ang="0">
-                <a:pos x="connsiteX0" y="connsiteY0"/>
+                <a:pos x="csX0" y="csY0"/>
               </a:cxn>
               <a:cxn ang="0">
-                <a:pos x="connsiteX1" y="connsiteY1"/>
+                <a:pos x="csX1" y="csY1"/>
               </a:cxn>
               <a:cxn ang="0">
-                <a:pos x="connsiteX2" y="connsiteY2"/>
+                <a:pos x="csX2" y="csY2"/>
               </a:cxn>
               <a:cxn ang="0">
-                <a:pos x="connsiteX3" y="connsiteY3"/>
+                <a:pos x="csX3" y="csY3"/>
               </a:cxn>
               <a:cxn ang="0">
-                <a:pos x="connsiteX4" y="connsiteY4"/>
+                <a:pos x="csX4" y="csY4"/>
               </a:cxn>
               <a:cxn ang="0">
-                <a:pos x="connsiteX5" y="connsiteY5"/>
+                <a:pos x="csX5" y="csY5"/>
               </a:cxn>
               <a:cxn ang="0">
-                <a:pos x="connsiteX6" y="connsiteY6"/>
+                <a:pos x="csX6" y="csY6"/>
               </a:cxn>
               <a:cxn ang="0">
-                <a:pos x="connsiteX7" y="connsiteY7"/>
+                <a:pos x="csX7" y="csY7"/>
               </a:cxn>
               <a:cxn ang="0">
-                <a:pos x="connsiteX8" y="connsiteY8"/>
+                <a:pos x="csX8" y="csY8"/>
               </a:cxn>
               <a:cxn ang="0">
-                <a:pos x="connsiteX9" y="connsiteY9"/>
+                <a:pos x="csX9" y="csY9"/>
               </a:cxn>
               <a:cxn ang="0">
-                <a:pos x="connsiteX10" y="connsiteY10"/>
+                <a:pos x="csX10" y="csY10"/>
               </a:cxn>
               <a:cxn ang="0">
-                <a:pos x="connsiteX11" y="connsiteY11"/>
+                <a:pos x="csX11" y="csY11"/>
               </a:cxn>
               <a:cxn ang="0">
-                <a:pos x="connsiteX12" y="connsiteY12"/>
+                <a:pos x="csX12" y="csY12"/>
               </a:cxn>
               <a:cxn ang="0">
-                <a:pos x="connsiteX13" y="connsiteY13"/>
+                <a:pos x="csX13" y="csY13"/>
               </a:cxn>
               <a:cxn ang="0">
-                <a:pos x="connsiteX14" y="connsiteY14"/>
+                <a:pos x="csX14" y="csY14"/>
               </a:cxn>
             </a:cxnLst>
             <a:rect l="l" t="t" r="r" b="b"/>
@@ -29848,6 +29848,83 @@
           </a:fontRef>
         </p:style>
       </p:cxnSp>
+      <p:sp>
+        <p:nvSpPr>
+          <p:cNvPr id="3" name="TextBox 2">
+            <a:extLst>
+              <a:ext uri="{FF2B5EF4-FFF2-40B4-BE49-F238E27FC236}">
+                <a16:creationId xmlns:a16="http://schemas.microsoft.com/office/drawing/2014/main" id="{72749AAA-3676-ABF5-C292-86E5C2C28AF8}"/>
+              </a:ext>
+            </a:extLst>
+          </p:cNvPr>
+          <p:cNvSpPr txBox="1"/>
+          <p:nvPr/>
+        </p:nvSpPr>
+        <p:spPr>
+          <a:xfrm>
+            <a:off x="5715000" y="1789331"/>
+            <a:ext cx="2362200" cy="307777"/>
+          </a:xfrm>
+          <a:prstGeom prst="rect">
+            <a:avLst/>
+          </a:prstGeom>
+          <a:noFill/>
+        </p:spPr>
+        <p:txBody>
+          <a:bodyPr wrap="square" rtlCol="0">
+            <a:spAutoFit/>
+          </a:bodyPr>
+          <a:lstStyle/>
+          <a:p>
+            <a:r>
+              <a:rPr lang="en-CA" sz="1400" dirty="0"/>
+              <a:t>Margins to compute sums</a:t>
+            </a:r>
+          </a:p>
+        </p:txBody>
+      </p:sp>
+      <p:cxnSp>
+        <p:nvCxnSpPr>
+          <p:cNvPr id="13" name="Straight Arrow Connector 12">
+            <a:extLst>
+              <a:ext uri="{FF2B5EF4-FFF2-40B4-BE49-F238E27FC236}">
+                <a16:creationId xmlns:a16="http://schemas.microsoft.com/office/drawing/2014/main" id="{A62C4FCB-BE50-639E-A7D2-CDA0D67128D9}"/>
+              </a:ext>
+            </a:extLst>
+          </p:cNvPr>
+          <p:cNvCxnSpPr/>
+          <p:nvPr/>
+        </p:nvCxnSpPr>
+        <p:spPr>
+          <a:xfrm flipH="1">
+            <a:off x="4876800" y="1892737"/>
+            <a:ext cx="685800" cy="317063"/>
+          </a:xfrm>
+          <a:prstGeom prst="straightConnector1">
+            <a:avLst/>
+          </a:prstGeom>
+          <a:ln w="22225">
+            <a:solidFill>
+              <a:srgbClr val="FF0000"/>
+            </a:solidFill>
+            <a:tailEnd type="triangle"/>
+          </a:ln>
+        </p:spPr>
+        <p:style>
+          <a:lnRef idx="1">
+            <a:schemeClr val="accent1"/>
+          </a:lnRef>
+          <a:fillRef idx="0">
+            <a:schemeClr val="accent1"/>
+          </a:fillRef>
+          <a:effectRef idx="0">
+            <a:schemeClr val="accent1"/>
+          </a:effectRef>
+          <a:fontRef idx="minor">
+            <a:schemeClr val="tx1"/>
+          </a:fontRef>
+        </p:style>
+      </p:cxnSp>
     </p:spTree>
     <p:extLst>
       <p:ext uri="{BB962C8B-B14F-4D97-AF65-F5344CB8AC3E}">
@@ -30099,6 +30176,57 @@
             <a:r>
               <a:rPr lang="en-CA" sz="1600" dirty="0"/>
               <a:t>Energy to compress ~ -log likelihood</a:t>
+            </a:r>
+          </a:p>
+        </p:txBody>
+      </p:sp>
+      <p:sp>
+        <p:nvSpPr>
+          <p:cNvPr id="8" name="TextBox 7">
+            <a:extLst>
+              <a:ext uri="{FF2B5EF4-FFF2-40B4-BE49-F238E27FC236}">
+                <a16:creationId xmlns:a16="http://schemas.microsoft.com/office/drawing/2014/main" id="{D129303C-B70A-9683-0921-A35523B7A45D}"/>
+              </a:ext>
+            </a:extLst>
+          </p:cNvPr>
+          <p:cNvSpPr txBox="1"/>
+          <p:nvPr/>
+        </p:nvSpPr>
+        <p:spPr>
+          <a:xfrm>
+            <a:off x="914400" y="6356350"/>
+            <a:ext cx="7190867" cy="276999"/>
+          </a:xfrm>
+          <a:prstGeom prst="rect">
+            <a:avLst/>
+          </a:prstGeom>
+          <a:noFill/>
+        </p:spPr>
+        <p:txBody>
+          <a:bodyPr wrap="square" rtlCol="0">
+            <a:spAutoFit/>
+          </a:bodyPr>
+          <a:lstStyle/>
+          <a:p>
+            <a:r>
+              <a:rPr lang="en-CA" sz="1200" dirty="0"/>
+              <a:t>Friendly, M. (1995). Conceptual and Visual Models for Categorical Data. </a:t>
+            </a:r>
+            <a:r>
+              <a:rPr lang="en-CA" sz="1200" i="1" dirty="0"/>
+              <a:t>The American Statistician</a:t>
+            </a:r>
+            <a:r>
+              <a:rPr lang="en-CA" sz="1200" dirty="0"/>
+              <a:t>, </a:t>
+            </a:r>
+            <a:r>
+              <a:rPr lang="en-CA" sz="1200" i="1" dirty="0"/>
+              <a:t>49</a:t>
+            </a:r>
+            <a:r>
+              <a:rPr lang="en-CA" sz="1200" dirty="0"/>
+              <a:t>, 153–160</a:t>
             </a:r>
           </a:p>
         </p:txBody>

</xml_diff>